<commit_message>
Add app summary PDF and generator script
Add a ReportLab script (Code/scripts/generate_app_summary_pdf.py) that generates a one-page Tearoma App Summary PDF and save it to Code/output/pdf/tearoma-app-summary.pdf (with a preview PNG). The PDF summarizes repo evidence (what it is, audience, features, architecture, run steps). Also add multiple Story/IdeiasFuturas writing screenshots and update Story docs/presentation and several .DS_Store metadata files.
</commit_message>
<xml_diff>
--- a/Story/IdeiasFuturas/Type chart.pptx
+++ b/Story/IdeiasFuturas/Type chart.pptx
@@ -104,6 +104,11 @@
       </a:defRPr>
     </a:lvl9pPr>
   </p:defaultTextStyle>
+  <p:extLst>
+    <p:ext uri="{EFAFB233-063F-42B5-8137-9DF3F51BA10A}">
+      <p15:sldGuideLst xmlns:p15="http://schemas.microsoft.com/office/powerpoint/2012/main"/>
+    </p:ext>
+  </p:extLst>
 </p:presentation>
 </file>
 
@@ -3304,7 +3309,7 @@
           <p:nvPr>
             <p:extLst>
               <p:ext uri="{D42A27DB-BD31-4B8C-83A1-F6EECF244321}">
-                <p14:modId xmlns:p14="http://schemas.microsoft.com/office/powerpoint/2010/main" val="519526330"/>
+                <p14:modId xmlns:p14="http://schemas.microsoft.com/office/powerpoint/2010/main" val="2113183545"/>
               </p:ext>
             </p:extLst>
           </p:nvPr>
@@ -11797,7 +11802,7 @@
                       </a:pPr>
                       <a:r>
                         <a:rPr lang="pt-PT" sz="700"/>
-                        <a:t>0.5</a:t>
+                        <a:t>2x</a:t>
                       </a:r>
                     </a:p>
                   </a:txBody>

</xml_diff>